<commit_message>
Update GitHub links to main account
</commit_message>
<xml_diff>
--- a/AI_Career_Search_Prompt_Beginners_Guide.pptx
+++ b/AI_Career_Search_Prompt_Beginners_Guide.pptx
@@ -119,18 +119,18 @@
   <p:extLst>
     <p:ext uri="{521415D9-36F7-43E2-AB2F-B90AF26B5E84}">
       <p14:sectionLst xmlns:p14="http://schemas.microsoft.com/office/powerpoint/2010/main">
-        <p14:section name="Start" id="{dafd3f6d-df13-e215-873a-bcc56c7ddc3d}">
+        <p14:section name="Start" id="{0bd48bff-e59a-b922-e060-39979ea97931}">
           <p14:sldIdLst>
             <p14:sldId id="256"/>
           </p14:sldIdLst>
         </p14:section>
-        <p14:section name="What it is" id="{f6dbf5cc-99bc-7620-f20e-d1f67974231f}">
+        <p14:section name="What it is" id="{e50defe0-41f8-c95a-69a9-f572d8ccfd34}">
           <p14:sldIdLst>
             <p14:sldId id="257"/>
             <p14:sldId id="258"/>
           </p14:sldIdLst>
         </p14:section>
-        <p14:section name="Step by step" id="{e9df4056-a4f0-f205-6c2b-2d2c6add7fce}">
+        <p14:section name="Step by step" id="{aa84896e-b656-d30d-8acd-e5beef2d347d}">
           <p14:sldIdLst>
             <p14:sldId id="259"/>
             <p14:sldId id="260"/>
@@ -140,14 +140,14 @@
             <p14:sldId id="264"/>
           </p14:sldIdLst>
         </p14:section>
-        <p14:section name="Good habits" id="{4d088609-9dbe-72e2-35dd-9ce8206a1df9}">
+        <p14:section name="Good habits" id="{c9f477d6-72cf-0f35-17d2-854045253699}">
           <p14:sldIdLst>
             <p14:sldId id="265"/>
             <p14:sldId id="266"/>
             <p14:sldId id="267"/>
           </p14:sldIdLst>
         </p14:section>
-        <p14:section name="Get it" id="{f8b65979-b790-1820-b8ff-0553d080ff90}">
+        <p14:section name="Get it" id="{9cde838a-0738-fa5e-6e44-52ec796d9a70}">
           <p14:sldIdLst>
             <p14:sldId id="268"/>
           </p14:sldIdLst>
@@ -4328,7 +4328,7 @@
                   </a:extLst>
                 </a:hlinkClick>
               </a:rPr>
-              <a:t>github.com/Abu1997-Pathan/ai-job-search-prompt</a:t>
+              <a:t>github.com/abuhurairahkhan1997-wq/ai-job-search-prompt</a:t>
             </a:r>
             <a:endParaRPr lang="en-US" sz="2200" dirty="0"/>
           </a:p>

</xml_diff>